<commit_message>
Deck and checklist: engine now runs on the phone
</commit_message>
<xml_diff>
--- a/submission/KANABI_SIH26168_IdeaPPT.pptx
+++ b/submission/KANABI_SIH26168_IdeaPPT.pptx
@@ -6354,7 +6354,7 @@
                 </a:solidFill>
                 <a:latin typeface="Arial"/>
               </a:rPr>
-              <a:t>Training happens on desktop (IO-VNBD); the lightweight model (32 k params, ONNX/TFLite) runs on the phone at 10 Hz and on the edge engine at ~200 Hz for external/FOG IMUs.</a:t>
+              <a:t>Training happens on desktop (IO-VNBD); the engine runs on the phone at sensor rate (pure Dart, no server) and the same core targets the edge engine at ~200 Hz for external/FOG IMUs; the 32 k-param CNN ships via ONNX/TFLite.</a:t>
             </a:r>
           </a:p>
         </p:txBody>
@@ -8573,7 +8573,7 @@
                 </a:solidFill>
                 <a:latin typeface="Arial"/>
               </a:rPr>
-              <a:t>Phase 2 (on-device, in progress): </a:t>
+              <a:t>Phase 2 (on-device, working): </a:t>
             </a:r>
             <a:r>
               <a:rPr sz="1100" b="0" i="0">
@@ -8582,7 +8582,7 @@
                 </a:solidFill>
                 <a:latin typeface="Arial"/>
               </a:rPr>
-              <a:t>Flutter app with live GNSS/IMU HUD and mode banner is built (APK); engine export to TFLite and porting of alignment + DR to the phone are next, followed by the 200 Hz edge build.</a:t>
+              <a:t>Android app runs alignment, pre-blackout calibration, dead reckoning and OSM map-matching on the phone (unit-tested on synthetic drives; APK in repo), with a simulate-tunnel switch and live drift read-out on GNSS return. Next: on-device ES-EKF fusion, 200 Hz edge build, real tunnel test.</a:t>
             </a:r>
           </a:p>
         </p:txBody>

</xml_diff>